<commit_message>
docs: update title slide layout in presentation deck
</commit_message>
<xml_diff>
--- a/presentation/campusfind.pptx
+++ b/presentation/campusfind.pptx
@@ -4340,7 +4340,7 @@
         </p:nvSpPr>
         <p:spPr>
           <a:xfrm>
-            <a:off x="1097280" y="1645920"/>
+            <a:off x="1097280" y="2011680"/>
             <a:ext cx="9966960" cy="1645920"/>
           </a:xfrm>
           <a:prstGeom prst="rect">
@@ -4369,7 +4369,7 @@
           <a:p>
             <a:pPr>
               <a:spcBef>
-                <a:spcPts val="1000"/>
+                <a:spcPts val="1200"/>
               </a:spcBef>
               <a:defRPr sz="2200">
                 <a:solidFill>
@@ -4392,7 +4392,7 @@
         </p:nvSpPr>
         <p:spPr>
           <a:xfrm>
-            <a:off x="1097280" y="3383280"/>
+            <a:off x="1097280" y="3840480"/>
             <a:ext cx="2011680" cy="27432"/>
           </a:xfrm>
           <a:prstGeom prst="rect">
@@ -4435,8 +4435,8 @@
         </p:nvSpPr>
         <p:spPr>
           <a:xfrm>
-            <a:off x="1097280" y="3749039"/>
-            <a:ext cx="9966960" cy="1828800"/>
+            <a:off x="1097280" y="4206240"/>
+            <a:ext cx="9966960" cy="731520"/>
           </a:xfrm>
           <a:prstGeom prst="rect">
             <a:avLst/>
@@ -4450,47 +4450,15 @@
           <a:lstStyle/>
           <a:p>
             <a:pPr>
-              <a:defRPr sz="2000" b="1">
-                <a:solidFill>
-                  <a:srgbClr val="1E293B"/>
+              <a:defRPr sz="2200">
+                <a:solidFill>
+                  <a:srgbClr val="334155"/>
                 </a:solidFill>
                 <a:latin typeface="Calibri"/>
               </a:defRPr>
             </a:pPr>
             <a:r>
-              <a:t>Engineering Design Review &amp; Implementation Defense</a:t>
-            </a:r>
-          </a:p>
-          <a:p>
-            <a:pPr>
-              <a:spcBef>
-                <a:spcPts val="800"/>
-              </a:spcBef>
-              <a:defRPr sz="1800">
-                <a:solidFill>
-                  <a:srgbClr val="334155"/>
-                </a:solidFill>
-                <a:latin typeface="Calibri"/>
-              </a:defRPr>
-            </a:pPr>
-            <a:r>
               <a:t>Presenter: Kavya Raghavendran</a:t>
-            </a:r>
-          </a:p>
-          <a:p>
-            <a:pPr>
-              <a:spcBef>
-                <a:spcPts val="600"/>
-              </a:spcBef>
-              <a:defRPr sz="1500">
-                <a:solidFill>
-                  <a:srgbClr val="64748B"/>
-                </a:solidFill>
-                <a:latin typeface="Calibri"/>
-              </a:defRPr>
-            </a:pPr>
-            <a:r>
-              <a:t>Technical Scope: Containerization, Supply Chain Security, AWS IaC, Kubernetes (Helm), and SRE Observability</a:t>
             </a:r>
           </a:p>
         </p:txBody>

</xml_diff>

<commit_message>
feat(ui): update status pills, row tints, sidebar tagline styling, track evidence and rebuild presentation
</commit_message>
<xml_diff>
--- a/presentation/campusfind.pptx
+++ b/presentation/campusfind.pptx
@@ -6329,8 +6329,8 @@
         </p:nvSpPr>
         <p:spPr>
           <a:xfrm>
-            <a:off x="5961888" y="1682496"/>
-            <a:ext cx="5541264" cy="3621024"/>
+            <a:off x="5961888" y="1970532"/>
+            <a:ext cx="5541264" cy="3044952"/>
           </a:xfrm>
           <a:prstGeom prst="rect">
             <a:avLst/>
@@ -6382,8 +6382,8 @@
         </p:blipFill>
         <p:spPr>
           <a:xfrm>
-            <a:off x="5989320" y="1709928"/>
-            <a:ext cx="5486400" cy="3566160"/>
+            <a:off x="5989320" y="1997964"/>
+            <a:ext cx="5486400" cy="2990088"/>
           </a:xfrm>
           <a:prstGeom prst="rect">
             <a:avLst/>

</xml_diff>